<commit_message>
Entregables al dia, desde el commit e149c9b del repositorio de trabajo
</commit_message>
<xml_diff>
--- a/ENTREGA FINAL/08 - Presentación de la defensa.pptx
+++ b/ENTREGA FINAL/08 - Presentación de la defensa.pptx
@@ -7375,7 +7375,7 @@
                 </a:solidFill>
                 <a:latin typeface="Calibri"/>
               </a:rPr>
-              <a:t>69</a:t>
+              <a:t>72</a:t>
             </a:r>
           </a:p>
         </p:txBody>
@@ -9266,7 +9266,7 @@
                 </a:solidFill>
                 <a:latin typeface="Calibri"/>
               </a:rPr>
-              <a:t>69</a:t>
+              <a:t>72</a:t>
             </a:r>
           </a:p>
         </p:txBody>

</xml_diff>

<commit_message>
Entregables al dia, desde el commit 693f4f9 del repositorio de trabajo
</commit_message>
<xml_diff>
--- a/ENTREGA FINAL/08 - Presentación de la defensa.pptx
+++ b/ENTREGA FINAL/08 - Presentación de la defensa.pptx
@@ -5025,7 +5025,7 @@
                 </a:solidFill>
                 <a:latin typeface="Calibri"/>
               </a:rPr>
-              <a:t>16/09/2026</a:t>
+              <a:t>17/09/2026</a:t>
             </a:r>
           </a:p>
         </p:txBody>
@@ -7375,7 +7375,7 @@
                 </a:solidFill>
                 <a:latin typeface="Calibri"/>
               </a:rPr>
-              <a:t>72</a:t>
+              <a:t>78</a:t>
             </a:r>
           </a:p>
         </p:txBody>
@@ -9266,7 +9266,7 @@
                 </a:solidFill>
                 <a:latin typeface="Calibri"/>
               </a:rPr>
-              <a:t>72</a:t>
+              <a:t>78</a:t>
             </a:r>
           </a:p>
         </p:txBody>

</xml_diff>

<commit_message>
Entregables al dia, desde el commit 4890eb3 del repositorio de trabajo
</commit_message>
<xml_diff>
--- a/ENTREGA FINAL/08 - Presentación de la defensa.pptx
+++ b/ENTREGA FINAL/08 - Presentación de la defensa.pptx
@@ -6255,7 +6255,7 @@
                 </a:solidFill>
                 <a:latin typeface="Calibri"/>
               </a:rPr>
-              <a:t>361</a:t>
+              <a:t>362</a:t>
             </a:r>
           </a:p>
         </p:txBody>
@@ -7375,7 +7375,7 @@
                 </a:solidFill>
                 <a:latin typeface="Calibri"/>
               </a:rPr>
-              <a:t>78</a:t>
+              <a:t>81</a:t>
             </a:r>
           </a:p>
         </p:txBody>
@@ -9032,7 +9032,7 @@
                 </a:solidFill>
                 <a:latin typeface="Calibri"/>
               </a:rPr>
-              <a:t>385</a:t>
+              <a:t>386</a:t>
             </a:r>
           </a:p>
         </p:txBody>
@@ -9266,7 +9266,7 @@
                 </a:solidFill>
                 <a:latin typeface="Calibri"/>
               </a:rPr>
-              <a:t>78</a:t>
+              <a:t>81</a:t>
             </a:r>
           </a:p>
         </p:txBody>

</xml_diff>